<commit_message>
Fix live website URL display in PPT slides 1, 2, and 10
Co-Authored-By: Claude Sonnet 4.6 <noreply@anthropic.com>
</commit_message>
<xml_diff>
--- a/RPA_Week2_Assignment.pptx
+++ b/RPA_Week2_Assignment.pptx
@@ -5069,12 +5069,12 @@
           <a:p>
             <a:pPr algn="ctr"/>
             <a:r>
-              <a:rPr sz="1000" b="0">
+              <a:rPr sz="900" b="0">
                 <a:solidFill>
                   <a:srgbClr val="88BBEE"/>
                 </a:solidFill>
               </a:rPr>
-              <a:t>GitHub: Live Site: https://omais-eng.github.io/rpa/assignment2/index.html  |  GitHub: https://github.com/omais-eng/rpa</a:t>
+              <a:t>Live Website: https://omais-eng.github.io/rpa/assignment2/index.html   |   GitHub: https://github.com/omais-eng/rpa</a:t>
             </a:r>
           </a:p>
         </p:txBody>
@@ -5677,12 +5677,12 @@
           <a:p>
             <a:pPr algn="ctr"/>
             <a:r>
-              <a:rPr sz="1000" b="0">
+              <a:rPr sz="900" b="0">
                 <a:solidFill>
-                  <a:srgbClr val="FFFFFF"/>
+                  <a:srgbClr val="88BBEE"/>
                 </a:solidFill>
               </a:rPr>
-              <a:t>GitHub: Live Site: https://omais-eng.github.io/rpa/assignment2/index.html  |  GitHub: https://github.com/omais-eng/rpa</a:t>
+              <a:t>Live Website: https://omais-eng.github.io/rpa/assignment2/index.html   |   GitHub: https://github.com/omais-eng/rpa</a:t>
             </a:r>
           </a:p>
         </p:txBody>
@@ -5883,10 +5883,10 @@
             <a:r>
               <a:rPr sz="900" b="0">
                 <a:solidFill>
-                  <a:srgbClr val="AACCEE"/>
+                  <a:srgbClr val="88BBEE"/>
                 </a:solidFill>
               </a:rPr>
-              <a:t>Live Website: Live Site: https://omais-eng.github.io/rpa/assignment2/index.html  |  GitHub: https://github.com/omais-eng/rpa/blob/main/assignment2/index.html  |  Open index.html in any browser</a:t>
+              <a:t>Live Site: https://omais-eng.github.io/rpa/assignment2/index.html  |  GitHub: https://github.com/omais-eng/rpa</a:t>
             </a:r>
           </a:p>
         </p:txBody>

</xml_diff>